<commit_message>
Acceso a la tienda en la última diapositiva de la evaluación McCall
Captura de la versión publicada, enlace y datos de prueba (usuario demo, tarjeta y cupón); textos más descriptivos en la evidencia del instrumento y en las acciones del plan de mejora.
</commit_message>
<xml_diff>
--- a/docs/semana_11/Evaluacion_McCall.pptx
+++ b/docs/semana_11/Evaluacion_McCall.pptx
@@ -565,7 +565,7 @@
           </a:prstGeom>
           <a:extLst>
             <a:ext uri="{C572A759-6A51-4108-AA02-DFA0A04FC94B}">
-              <ma14:wrappingTextBoxFlag xmlns:ma14="http://schemas.microsoft.com/office/mac/drawingml/2011/main" xmlns="" val="0"/>
+              <ma14:wrappingTextBoxFlag xmlns="" xmlns:ma14="http://schemas.microsoft.com/office/mac/drawingml/2011/main" val="0"/>
             </a:ext>
           </a:extLst>
         </p:spPr>
@@ -643,7 +643,7 @@
           </a:prstGeom>
           <a:extLst>
             <a:ext uri="{C572A759-6A51-4108-AA02-DFA0A04FC94B}">
-              <ma14:wrappingTextBoxFlag xmlns:ma14="http://schemas.microsoft.com/office/mac/drawingml/2011/main" xmlns="" val="0"/>
+              <ma14:wrappingTextBoxFlag xmlns="" xmlns:ma14="http://schemas.microsoft.com/office/mac/drawingml/2011/main" val="0"/>
             </a:ext>
           </a:extLst>
         </p:spPr>
@@ -1305,7 +1305,7 @@
           </a:prstGeom>
           <a:extLst>
             <a:ext uri="{C572A759-6A51-4108-AA02-DFA0A04FC94B}">
-              <ma14:wrappingTextBoxFlag xmlns:ma14="http://schemas.microsoft.com/office/mac/drawingml/2011/main" xmlns="" val="0"/>
+              <ma14:wrappingTextBoxFlag xmlns="" xmlns:ma14="http://schemas.microsoft.com/office/mac/drawingml/2011/main" val="0"/>
             </a:ext>
           </a:extLst>
         </p:spPr>
@@ -2082,7 +2082,7 @@
           </a:prstGeom>
           <a:extLst>
             <a:ext uri="{C572A759-6A51-4108-AA02-DFA0A04FC94B}">
-              <ma14:wrappingTextBoxFlag xmlns:ma14="http://schemas.microsoft.com/office/mac/drawingml/2011/main" xmlns="" val="0"/>
+              <ma14:wrappingTextBoxFlag xmlns="" xmlns:ma14="http://schemas.microsoft.com/office/mac/drawingml/2011/main" val="0"/>
             </a:ext>
           </a:extLst>
         </p:spPr>
@@ -3578,7 +3578,7 @@
           </a:prstGeom>
           <a:extLst>
             <a:ext uri="{C572A759-6A51-4108-AA02-DFA0A04FC94B}">
-              <ma14:wrappingTextBoxFlag xmlns:ma14="http://schemas.microsoft.com/office/mac/drawingml/2011/main" xmlns="" val="0"/>
+              <ma14:wrappingTextBoxFlag xmlns="" xmlns:ma14="http://schemas.microsoft.com/office/mac/drawingml/2011/main" val="0"/>
             </a:ext>
           </a:extLst>
         </p:spPr>
@@ -4663,7 +4663,7 @@
           </a:prstGeom>
           <a:extLst>
             <a:ext uri="{C572A759-6A51-4108-AA02-DFA0A04FC94B}">
-              <ma14:wrappingTextBoxFlag xmlns:ma14="http://schemas.microsoft.com/office/mac/drawingml/2011/main" xmlns="" val="0"/>
+              <ma14:wrappingTextBoxFlag xmlns="" xmlns:ma14="http://schemas.microsoft.com/office/mac/drawingml/2011/main" val="0"/>
             </a:ext>
           </a:extLst>
         </p:spPr>
@@ -5441,7 +5441,7 @@
           </a:prstGeom>
           <a:extLst>
             <a:ext uri="{C572A759-6A51-4108-AA02-DFA0A04FC94B}">
-              <ma14:wrappingTextBoxFlag xmlns:ma14="http://schemas.microsoft.com/office/mac/drawingml/2011/main" xmlns="" val="0"/>
+              <ma14:wrappingTextBoxFlag xmlns="" xmlns:ma14="http://schemas.microsoft.com/office/mac/drawingml/2011/main" val="0"/>
             </a:ext>
           </a:extLst>
         </p:spPr>
@@ -6217,7 +6217,7 @@
           </a:prstGeom>
           <a:extLst>
             <a:ext uri="{C572A759-6A51-4108-AA02-DFA0A04FC94B}">
-              <ma14:wrappingTextBoxFlag xmlns:ma14="http://schemas.microsoft.com/office/mac/drawingml/2011/main" xmlns="" val="0"/>
+              <ma14:wrappingTextBoxFlag xmlns="" xmlns:ma14="http://schemas.microsoft.com/office/mac/drawingml/2011/main" val="0"/>
             </a:ext>
           </a:extLst>
         </p:spPr>
@@ -6663,7 +6663,7 @@
           </a:prstGeom>
           <a:extLst>
             <a:ext uri="{C572A759-6A51-4108-AA02-DFA0A04FC94B}">
-              <ma14:wrappingTextBoxFlag xmlns:ma14="http://schemas.microsoft.com/office/mac/drawingml/2011/main" xmlns="" val="0"/>
+              <ma14:wrappingTextBoxFlag xmlns="" xmlns:ma14="http://schemas.microsoft.com/office/mac/drawingml/2011/main" val="0"/>
             </a:ext>
           </a:extLst>
         </p:spPr>
@@ -7714,115 +7714,9 @@
                 <a:ea typeface="Calibri" pitchFamily="34" charset="-122"/>
                 <a:cs typeface="Calibri" pitchFamily="34" charset="-120"/>
               </a:rPr>
-              <a:t>Conclusiones y recomendaciones</a:t>
+              <a:t>Datos de la tienda</a:t>
             </a:r>
             <a:endParaRPr lang="en-US" sz="2800" dirty="0"/>
-          </a:p>
-        </p:txBody>
-      </p:sp>
-      <p:sp>
-        <p:nvSpPr>
-          <p:cNvPr id="3" name="Text 1"/>
-          <p:cNvSpPr txBox="1"/>
-          <p:nvPr/>
-        </p:nvSpPr>
-        <p:spPr>
-          <a:xfrm>
-            <a:off x="731520" y="1143000"/>
-            <a:ext cx="3840480" cy="2743200"/>
-          </a:xfrm>
-          <a:prstGeom prst="rect">
-            <a:avLst/>
-          </a:prstGeom>
-          <a:noFill/>
-          <a:ln/>
-        </p:spPr>
-        <p:txBody>
-          <a:bodyPr wrap="square" lIns="0" tIns="0" rIns="0" bIns="0" rtlCol="0" anchor="t"/>
-          <a:lstStyle/>
-          <a:p>
-            <a:pPr marL="152400" indent="-152400">
-              <a:spcAft>
-                <a:spcPts val="800"/>
-              </a:spcAft>
-              <a:buSzPct val="100000"/>
-              <a:buChar char="•"/>
-            </a:pPr>
-            <a:r>
-              <a:rPr lang="en-US" sz="1500" dirty="0">
-                <a:solidFill>
-                  <a:srgbClr val="C9D3E3"/>
-                </a:solidFill>
-                <a:latin typeface="Calibri" pitchFamily="34" charset="0"/>
-                <a:ea typeface="Calibri" pitchFamily="34" charset="-122"/>
-                <a:cs typeface="Calibri" pitchFamily="34" charset="-120"/>
-              </a:rPr>
-              <a:t>TechStore obtiene 4,1/5 (82 %) en McCall: calidad «Bueno».</a:t>
-            </a:r>
-            <a:endParaRPr lang="en-US" sz="1500" dirty="0"/>
-          </a:p>
-          <a:p>
-            <a:pPr marL="152400" indent="-152400">
-              <a:spcAft>
-                <a:spcPts val="800"/>
-              </a:spcAft>
-              <a:buSzPct val="100000"/>
-              <a:buChar char="•"/>
-            </a:pPr>
-            <a:r>
-              <a:rPr lang="en-US" sz="1500" dirty="0">
-                <a:solidFill>
-                  <a:srgbClr val="C9D3E3"/>
-                </a:solidFill>
-                <a:latin typeface="Calibri" pitchFamily="34" charset="0"/>
-                <a:ea typeface="Calibri" pitchFamily="34" charset="-122"/>
-                <a:cs typeface="Calibri" pitchFamily="34" charset="-120"/>
-              </a:rPr>
-              <a:t>La calidad es multidimensional: corrección 5,0 frente a interoperabilidad 2,0.</a:t>
-            </a:r>
-            <a:endParaRPr lang="en-US" sz="1500" dirty="0"/>
-          </a:p>
-          <a:p>
-            <a:pPr marL="152400" indent="-152400">
-              <a:spcAft>
-                <a:spcPts val="800"/>
-              </a:spcAft>
-              <a:buSzPct val="100000"/>
-              <a:buChar char="•"/>
-            </a:pPr>
-            <a:r>
-              <a:rPr lang="en-US" sz="1500" dirty="0">
-                <a:solidFill>
-                  <a:srgbClr val="C9D3E3"/>
-                </a:solidFill>
-                <a:latin typeface="Calibri" pitchFamily="34" charset="0"/>
-                <a:ea typeface="Calibri" pitchFamily="34" charset="-122"/>
-                <a:cs typeface="Calibri" pitchFamily="34" charset="-120"/>
-              </a:rPr>
-              <a:t>McCall complementa a ISO/IEC 25010: la transición mostró lo que no medíamos.</a:t>
-            </a:r>
-            <a:endParaRPr lang="en-US" sz="1500" dirty="0"/>
-          </a:p>
-          <a:p>
-            <a:pPr marL="152400" indent="-152400">
-              <a:spcAft>
-                <a:spcPts val="800"/>
-              </a:spcAft>
-              <a:buSzPct val="100000"/>
-              <a:buChar char="•"/>
-            </a:pPr>
-            <a:r>
-              <a:rPr lang="en-US" sz="1500" dirty="0">
-                <a:solidFill>
-                  <a:srgbClr val="C9D3E3"/>
-                </a:solidFill>
-                <a:latin typeface="Calibri" pitchFamily="34" charset="0"/>
-                <a:ea typeface="Calibri" pitchFamily="34" charset="-122"/>
-                <a:cs typeface="Calibri" pitchFamily="34" charset="-120"/>
-              </a:rPr>
-              <a:t>Las debilidades vienen del alcance (sin backend), no de defectos.</a:t>
-            </a:r>
-            <a:endParaRPr lang="en-US" sz="1500" dirty="0"/>
           </a:p>
         </p:txBody>
       </p:sp>
@@ -7834,7 +7728,7 @@
         </p:nvSpPr>
         <p:spPr>
           <a:xfrm>
-            <a:off x="4937760" y="1097280"/>
+            <a:off x="4445390" y="502920"/>
             <a:ext cx="3474720" cy="365760"/>
           </a:xfrm>
           <a:prstGeom prst="rect">
@@ -7859,488 +7753,186 @@
                 <a:ea typeface="Calibri" pitchFamily="34" charset="-122"/>
                 <a:cs typeface="Calibri" pitchFamily="34" charset="-120"/>
               </a:rPr>
-              <a:t>Recomendaciones</a:t>
+              <a:t>Prueba TechStore</a:t>
             </a:r>
             <a:endParaRPr lang="en-US" sz="1600" dirty="0"/>
           </a:p>
         </p:txBody>
       </p:sp>
+      <p:pic>
+        <p:nvPicPr>
+          <p:cNvPr id="18" name="Picture 17" descr="techstore_shot_c.png"/>
+          <p:cNvPicPr>
+            <a:picLocks noChangeAspect="1"/>
+          </p:cNvPicPr>
+          <p:nvPr/>
+        </p:nvPicPr>
+        <p:blipFill>
+          <a:blip r:embed="rId3"/>
+          <a:stretch>
+            <a:fillRect/>
+          </a:stretch>
+        </p:blipFill>
+        <p:spPr>
+          <a:xfrm>
+            <a:off x="485335" y="1171135"/>
+            <a:ext cx="4253147" cy="2690447"/>
+          </a:xfrm>
+          <a:prstGeom prst="rect">
+            <a:avLst/>
+          </a:prstGeom>
+          <a:ln w="9525">
+            <a:solidFill>
+              <a:srgbClr val="C9D3E3"/>
+            </a:solidFill>
+          </a:ln>
+        </p:spPr>
+      </p:pic>
       <p:sp>
         <p:nvSpPr>
-          <p:cNvPr id="5" name="Shape 3"/>
-          <p:cNvSpPr/>
-          <p:nvPr/>
-        </p:nvSpPr>
-        <p:spPr>
-          <a:xfrm>
-            <a:off x="4937760" y="1554480"/>
-            <a:ext cx="384048" cy="384048"/>
-          </a:xfrm>
-          <a:prstGeom prst="ellipse">
-            <a:avLst/>
-          </a:prstGeom>
-          <a:solidFill>
-            <a:srgbClr val="FCA311"/>
-          </a:solidFill>
-          <a:ln w="12700">
-            <a:solidFill>
-              <a:srgbClr val="FCA311"/>
-            </a:solidFill>
-            <a:prstDash val="solid"/>
-          </a:ln>
-        </p:spPr>
-        <p:txBody>
-          <a:bodyPr/>
-          <a:lstStyle/>
-          <a:p>
-            <a:endParaRPr lang="es-PE"/>
-          </a:p>
-        </p:txBody>
-      </p:sp>
-      <p:sp>
-        <p:nvSpPr>
-          <p:cNvPr id="6" name="Text 4"/>
+          <p:cNvPr id="19" name="TextBox 18"/>
           <p:cNvSpPr txBox="1"/>
           <p:nvPr/>
         </p:nvSpPr>
         <p:spPr>
           <a:xfrm>
-            <a:off x="4937760" y="1554480"/>
-            <a:ext cx="384048" cy="384048"/>
+            <a:off x="5183945" y="1171135"/>
+            <a:ext cx="3474720" cy="1201769"/>
           </a:xfrm>
           <a:prstGeom prst="rect">
             <a:avLst/>
           </a:prstGeom>
           <a:noFill/>
-          <a:ln/>
         </p:spPr>
         <p:txBody>
-          <a:bodyPr wrap="square" lIns="0" tIns="0" rIns="0" bIns="0" rtlCol="0" anchor="ctr"/>
+          <a:bodyPr wrap="square" lIns="0" tIns="0" rIns="0" bIns="0">
+            <a:spAutoFit/>
+          </a:bodyPr>
           <a:lstStyle/>
           <a:p>
-            <a:pPr marL="0" indent="0" algn="ctr">
-              <a:buNone/>
+            <a:pPr>
+              <a:spcAft>
+                <a:spcPts val="300"/>
+              </a:spcAft>
             </a:pPr>
             <a:r>
-              <a:rPr lang="en-US" sz="1300" b="1" dirty="0">
+              <a:rPr sz="1100" b="1">
                 <a:solidFill>
-                  <a:srgbClr val="14213D"/>
+                  <a:srgbClr val="F6AD55"/>
                 </a:solidFill>
-                <a:latin typeface="Calibri" pitchFamily="34" charset="0"/>
-                <a:ea typeface="Calibri" pitchFamily="34" charset="-122"/>
-                <a:cs typeface="Calibri" pitchFamily="34" charset="-120"/>
+                <a:latin typeface="Calibri"/>
               </a:rPr>
-              <a:t>1</a:t>
+              <a:t>Enlace: </a:t>
             </a:r>
-            <a:endParaRPr lang="en-US" sz="1300" dirty="0"/>
-          </a:p>
-        </p:txBody>
-      </p:sp>
-      <p:sp>
-        <p:nvSpPr>
-          <p:cNvPr id="7" name="Text 5"/>
-          <p:cNvSpPr txBox="1"/>
-          <p:nvPr/>
-        </p:nvSpPr>
-        <p:spPr>
-          <a:xfrm>
-            <a:off x="5486400" y="1554480"/>
-            <a:ext cx="3017520" cy="384048"/>
-          </a:xfrm>
-          <a:prstGeom prst="rect">
-            <a:avLst/>
-          </a:prstGeom>
-          <a:noFill/>
-          <a:ln/>
-        </p:spPr>
-        <p:txBody>
-          <a:bodyPr wrap="square" lIns="0" tIns="0" rIns="0" bIns="0" rtlCol="0" anchor="ctr"/>
-          <a:lstStyle/>
-          <a:p>
-            <a:pPr marL="0" indent="0">
-              <a:buNone/>
-            </a:pPr>
             <a:r>
-              <a:rPr lang="en-US" sz="1400" dirty="0">
+              <a:rPr sz="1100" b="0" u="sng">
                 <a:solidFill>
                   <a:srgbClr val="FFFFFF"/>
                 </a:solidFill>
-                <a:latin typeface="Calibri" pitchFamily="34" charset="0"/>
-                <a:ea typeface="Calibri" pitchFamily="34" charset="-122"/>
-                <a:cs typeface="Calibri" pitchFamily="34" charset="-120"/>
+                <a:latin typeface="Calibri"/>
+                <a:hlinkClick r:id="rId4">
+                  <a:extLst>
+                    <a:ext uri="{A12FA001-AC4F-418D-AE19-62706E023703}">
+                      <ahyp:hlinkClr xmlns:ahyp="http://schemas.microsoft.com/office/drawing/2018/hyperlinkcolor" val="tx"/>
+                    </a:ext>
+                  </a:extLst>
+                </a:hlinkClick>
               </a:rPr>
-              <a:t>Aplicar McCall desde el diseño</a:t>
+              <a:t>https://diegoaaron.github.io/calidadProyecto/</a:t>
             </a:r>
-            <a:endParaRPr lang="en-US" sz="1400" dirty="0"/>
           </a:p>
-        </p:txBody>
-      </p:sp>
-      <p:sp>
-        <p:nvSpPr>
-          <p:cNvPr id="8" name="Shape 6"/>
-          <p:cNvSpPr/>
-          <p:nvPr/>
-        </p:nvSpPr>
-        <p:spPr>
-          <a:xfrm>
-            <a:off x="4937760" y="2121408"/>
-            <a:ext cx="384048" cy="384048"/>
-          </a:xfrm>
-          <a:prstGeom prst="ellipse">
-            <a:avLst/>
-          </a:prstGeom>
-          <a:solidFill>
-            <a:srgbClr val="FCA311"/>
-          </a:solidFill>
-          <a:ln w="12700">
-            <a:solidFill>
-              <a:srgbClr val="FCA311"/>
-            </a:solidFill>
-            <a:prstDash val="solid"/>
-          </a:ln>
-        </p:spPr>
-        <p:txBody>
-          <a:bodyPr/>
-          <a:lstStyle/>
           <a:p>
-            <a:endParaRPr lang="es-PE"/>
-          </a:p>
-        </p:txBody>
-      </p:sp>
-      <p:sp>
-        <p:nvSpPr>
-          <p:cNvPr id="9" name="Text 7"/>
-          <p:cNvSpPr txBox="1"/>
-          <p:nvPr/>
-        </p:nvSpPr>
-        <p:spPr>
-          <a:xfrm>
-            <a:off x="4937760" y="2121408"/>
-            <a:ext cx="384048" cy="384048"/>
-          </a:xfrm>
-          <a:prstGeom prst="rect">
-            <a:avLst/>
-          </a:prstGeom>
-          <a:noFill/>
-          <a:ln/>
-        </p:spPr>
-        <p:txBody>
-          <a:bodyPr wrap="square" lIns="0" tIns="0" rIns="0" bIns="0" rtlCol="0" anchor="ctr"/>
-          <a:lstStyle/>
-          <a:p>
-            <a:pPr marL="0" indent="0" algn="ctr">
-              <a:buNone/>
+            <a:pPr>
+              <a:spcAft>
+                <a:spcPts val="300"/>
+              </a:spcAft>
             </a:pPr>
             <a:r>
-              <a:rPr lang="en-US" sz="1300" b="1" dirty="0">
+              <a:rPr sz="1100" b="1">
                 <a:solidFill>
-                  <a:srgbClr val="14213D"/>
+                  <a:srgbClr val="F6AD55"/>
                 </a:solidFill>
-                <a:latin typeface="Calibri" pitchFamily="34" charset="0"/>
-                <a:ea typeface="Calibri" pitchFamily="34" charset="-122"/>
-                <a:cs typeface="Calibri" pitchFamily="34" charset="-120"/>
+                <a:latin typeface="Calibri"/>
               </a:rPr>
-              <a:t>2</a:t>
+              <a:t>Usuario: </a:t>
             </a:r>
-            <a:endParaRPr lang="en-US" sz="1300" dirty="0"/>
+            <a:r>
+              <a:rPr sz="1100" b="0">
+                <a:solidFill>
+                  <a:srgbClr val="C9D3E3"/>
+                </a:solidFill>
+                <a:latin typeface="Calibri"/>
+              </a:rPr>
+              <a:t>demo@techstore.pe</a:t>
+            </a:r>
+            <a:r>
+              <a:rPr sz="1100" b="1">
+                <a:solidFill>
+                  <a:srgbClr val="F6AD55"/>
+                </a:solidFill>
+                <a:latin typeface="Calibri"/>
+              </a:rPr>
+              <a:t>   Clave: </a:t>
+            </a:r>
+            <a:r>
+              <a:rPr sz="1100" b="0">
+                <a:solidFill>
+                  <a:srgbClr val="C9D3E3"/>
+                </a:solidFill>
+                <a:latin typeface="Calibri"/>
+              </a:rPr>
+              <a:t>Demo@1234</a:t>
+            </a:r>
           </a:p>
-        </p:txBody>
-      </p:sp>
-      <p:sp>
-        <p:nvSpPr>
-          <p:cNvPr id="10" name="Text 8"/>
-          <p:cNvSpPr txBox="1"/>
-          <p:nvPr/>
-        </p:nvSpPr>
-        <p:spPr>
-          <a:xfrm>
-            <a:off x="5486400" y="2121408"/>
-            <a:ext cx="3017520" cy="384048"/>
-          </a:xfrm>
-          <a:prstGeom prst="rect">
-            <a:avLst/>
-          </a:prstGeom>
-          <a:noFill/>
-          <a:ln/>
-        </p:spPr>
-        <p:txBody>
-          <a:bodyPr wrap="square" lIns="0" tIns="0" rIns="0" bIns="0" rtlCol="0" anchor="ctr"/>
-          <a:lstStyle/>
           <a:p>
-            <a:pPr marL="0" indent="0">
-              <a:buNone/>
+            <a:pPr>
+              <a:spcAft>
+                <a:spcPts val="300"/>
+              </a:spcAft>
             </a:pPr>
             <a:r>
-              <a:rPr lang="en-US" sz="1400" dirty="0">
+              <a:rPr sz="1100" b="1">
                 <a:solidFill>
-                  <a:srgbClr val="FFFFFF"/>
+                  <a:srgbClr val="F6AD55"/>
                 </a:solidFill>
-                <a:latin typeface="Calibri" pitchFamily="34" charset="0"/>
-                <a:ea typeface="Calibri" pitchFamily="34" charset="-122"/>
-                <a:cs typeface="Calibri" pitchFamily="34" charset="-120"/>
+                <a:latin typeface="Calibri"/>
               </a:rPr>
-              <a:t>Un RNF y una métrica por factor</a:t>
+              <a:t>Tarjeta: </a:t>
             </a:r>
-            <a:endParaRPr lang="en-US" sz="1400" dirty="0"/>
+            <a:r>
+              <a:rPr sz="1100" b="0">
+                <a:solidFill>
+                  <a:srgbClr val="C9D3E3"/>
+                </a:solidFill>
+                <a:latin typeface="Calibri"/>
+              </a:rPr>
+              <a:t>4111 1111 1111 1111 · vence 12/30 · CVV 123</a:t>
+            </a:r>
           </a:p>
-        </p:txBody>
-      </p:sp>
-      <p:sp>
-        <p:nvSpPr>
-          <p:cNvPr id="11" name="Shape 9"/>
-          <p:cNvSpPr/>
-          <p:nvPr/>
-        </p:nvSpPr>
-        <p:spPr>
-          <a:xfrm>
-            <a:off x="4937760" y="2688336"/>
-            <a:ext cx="384048" cy="384048"/>
-          </a:xfrm>
-          <a:prstGeom prst="ellipse">
-            <a:avLst/>
-          </a:prstGeom>
-          <a:solidFill>
-            <a:srgbClr val="FCA311"/>
-          </a:solidFill>
-          <a:ln w="12700">
-            <a:solidFill>
-              <a:srgbClr val="FCA311"/>
-            </a:solidFill>
-            <a:prstDash val="solid"/>
-          </a:ln>
-        </p:spPr>
-        <p:txBody>
-          <a:bodyPr/>
-          <a:lstStyle/>
           <a:p>
-            <a:endParaRPr lang="es-PE"/>
-          </a:p>
-        </p:txBody>
-      </p:sp>
-      <p:sp>
-        <p:nvSpPr>
-          <p:cNvPr id="12" name="Text 10"/>
-          <p:cNvSpPr txBox="1"/>
-          <p:nvPr/>
-        </p:nvSpPr>
-        <p:spPr>
-          <a:xfrm>
-            <a:off x="4937760" y="2688336"/>
-            <a:ext cx="384048" cy="384048"/>
-          </a:xfrm>
-          <a:prstGeom prst="rect">
-            <a:avLst/>
-          </a:prstGeom>
-          <a:noFill/>
-          <a:ln/>
-        </p:spPr>
-        <p:txBody>
-          <a:bodyPr wrap="square" lIns="0" tIns="0" rIns="0" bIns="0" rtlCol="0" anchor="ctr"/>
-          <a:lstStyle/>
-          <a:p>
-            <a:pPr marL="0" indent="0" algn="ctr">
-              <a:buNone/>
+            <a:pPr>
+              <a:spcAft>
+                <a:spcPts val="300"/>
+              </a:spcAft>
             </a:pPr>
             <a:r>
-              <a:rPr lang="en-US" sz="1300" b="1" dirty="0">
+              <a:rPr sz="1100" b="1">
                 <a:solidFill>
-                  <a:srgbClr val="14213D"/>
+                  <a:srgbClr val="F6AD55"/>
                 </a:solidFill>
-                <a:latin typeface="Calibri" pitchFamily="34" charset="0"/>
-                <a:ea typeface="Calibri" pitchFamily="34" charset="-122"/>
-                <a:cs typeface="Calibri" pitchFamily="34" charset="-120"/>
+                <a:latin typeface="Calibri"/>
               </a:rPr>
-              <a:t>3</a:t>
+              <a:t>Cupón: </a:t>
             </a:r>
-            <a:endParaRPr lang="en-US" sz="1300" dirty="0"/>
-          </a:p>
-        </p:txBody>
-      </p:sp>
-      <p:sp>
-        <p:nvSpPr>
-          <p:cNvPr id="13" name="Text 11"/>
-          <p:cNvSpPr txBox="1"/>
-          <p:nvPr/>
-        </p:nvSpPr>
-        <p:spPr>
-          <a:xfrm>
-            <a:off x="5486400" y="2688336"/>
-            <a:ext cx="3017520" cy="384048"/>
-          </a:xfrm>
-          <a:prstGeom prst="rect">
-            <a:avLst/>
-          </a:prstGeom>
-          <a:noFill/>
-          <a:ln/>
-        </p:spPr>
-        <p:txBody>
-          <a:bodyPr wrap="square" lIns="0" tIns="0" rIns="0" bIns="0" rtlCol="0" anchor="ctr"/>
-          <a:lstStyle/>
-          <a:p>
-            <a:pPr marL="0" indent="0">
-              <a:buNone/>
-            </a:pPr>
             <a:r>
-              <a:rPr lang="en-US" sz="1400" dirty="0">
+              <a:rPr sz="1100" b="0">
                 <a:solidFill>
-                  <a:srgbClr val="FFFFFF"/>
+                  <a:srgbClr val="C9D3E3"/>
                 </a:solidFill>
-                <a:latin typeface="Calibri" pitchFamily="34" charset="0"/>
-                <a:ea typeface="Calibri" pitchFamily="34" charset="-122"/>
-                <a:cs typeface="Calibri" pitchFamily="34" charset="-120"/>
+                <a:latin typeface="Calibri"/>
               </a:rPr>
-              <a:t>Reaplicar el instrumento en cada versión</a:t>
+              <a:t>BIENVENIDO10 (10 % de descuento)</a:t>
             </a:r>
-            <a:endParaRPr lang="en-US" sz="1400" dirty="0"/>
-          </a:p>
-        </p:txBody>
-      </p:sp>
-      <p:sp>
-        <p:nvSpPr>
-          <p:cNvPr id="14" name="Shape 12"/>
-          <p:cNvSpPr/>
-          <p:nvPr/>
-        </p:nvSpPr>
-        <p:spPr>
-          <a:xfrm>
-            <a:off x="4937760" y="3255264"/>
-            <a:ext cx="384048" cy="384048"/>
-          </a:xfrm>
-          <a:prstGeom prst="ellipse">
-            <a:avLst/>
-          </a:prstGeom>
-          <a:solidFill>
-            <a:srgbClr val="FCA311"/>
-          </a:solidFill>
-          <a:ln w="12700">
-            <a:solidFill>
-              <a:srgbClr val="FCA311"/>
-            </a:solidFill>
-            <a:prstDash val="solid"/>
-          </a:ln>
-        </p:spPr>
-        <p:txBody>
-          <a:bodyPr/>
-          <a:lstStyle/>
-          <a:p>
-            <a:endParaRPr lang="es-PE"/>
-          </a:p>
-        </p:txBody>
-      </p:sp>
-      <p:sp>
-        <p:nvSpPr>
-          <p:cNvPr id="15" name="Text 13"/>
-          <p:cNvSpPr txBox="1"/>
-          <p:nvPr/>
-        </p:nvSpPr>
-        <p:spPr>
-          <a:xfrm>
-            <a:off x="4937760" y="3255264"/>
-            <a:ext cx="384048" cy="384048"/>
-          </a:xfrm>
-          <a:prstGeom prst="rect">
-            <a:avLst/>
-          </a:prstGeom>
-          <a:noFill/>
-          <a:ln/>
-        </p:spPr>
-        <p:txBody>
-          <a:bodyPr wrap="square" lIns="0" tIns="0" rIns="0" bIns="0" rtlCol="0" anchor="ctr"/>
-          <a:lstStyle/>
-          <a:p>
-            <a:pPr marL="0" indent="0" algn="ctr">
-              <a:buNone/>
-            </a:pPr>
-            <a:r>
-              <a:rPr lang="en-US" sz="1300" b="1" dirty="0">
-                <a:solidFill>
-                  <a:srgbClr val="14213D"/>
-                </a:solidFill>
-                <a:latin typeface="Calibri" pitchFamily="34" charset="0"/>
-                <a:ea typeface="Calibri" pitchFamily="34" charset="-122"/>
-                <a:cs typeface="Calibri" pitchFamily="34" charset="-120"/>
-              </a:rPr>
-              <a:t>4</a:t>
-            </a:r>
-            <a:endParaRPr lang="en-US" sz="1300" dirty="0"/>
-          </a:p>
-        </p:txBody>
-      </p:sp>
-      <p:sp>
-        <p:nvSpPr>
-          <p:cNvPr id="16" name="Text 14"/>
-          <p:cNvSpPr txBox="1"/>
-          <p:nvPr/>
-        </p:nvSpPr>
-        <p:spPr>
-          <a:xfrm>
-            <a:off x="5486400" y="3255264"/>
-            <a:ext cx="3017520" cy="384048"/>
-          </a:xfrm>
-          <a:prstGeom prst="rect">
-            <a:avLst/>
-          </a:prstGeom>
-          <a:noFill/>
-          <a:ln/>
-        </p:spPr>
-        <p:txBody>
-          <a:bodyPr wrap="square" lIns="0" tIns="0" rIns="0" bIns="0" rtlCol="0" anchor="ctr"/>
-          <a:lstStyle/>
-          <a:p>
-            <a:pPr marL="0" indent="0">
-              <a:buNone/>
-            </a:pPr>
-            <a:r>
-              <a:rPr lang="en-US" sz="1400" dirty="0">
-                <a:solidFill>
-                  <a:srgbClr val="FFFFFF"/>
-                </a:solidFill>
-                <a:latin typeface="Calibri" pitchFamily="34" charset="0"/>
-                <a:ea typeface="Calibri" pitchFamily="34" charset="-122"/>
-                <a:cs typeface="Calibri" pitchFamily="34" charset="-120"/>
-              </a:rPr>
-              <a:t>Confirmar usabilidad con usuarios reales</a:t>
-            </a:r>
-            <a:endParaRPr lang="en-US" sz="1400" dirty="0"/>
-          </a:p>
-        </p:txBody>
-      </p:sp>
-      <p:sp>
-        <p:nvSpPr>
-          <p:cNvPr id="17" name="Text 15"/>
-          <p:cNvSpPr txBox="1"/>
-          <p:nvPr/>
-        </p:nvSpPr>
-        <p:spPr>
-          <a:xfrm>
-            <a:off x="731520" y="4206240"/>
-            <a:ext cx="7680960" cy="411480"/>
-          </a:xfrm>
-          <a:prstGeom prst="rect">
-            <a:avLst/>
-          </a:prstGeom>
-          <a:noFill/>
-          <a:ln/>
-        </p:spPr>
-        <p:txBody>
-          <a:bodyPr wrap="square" lIns="0" tIns="0" rIns="0" bIns="0" rtlCol="0" anchor="ctr"/>
-          <a:lstStyle/>
-          <a:p>
-            <a:pPr marL="0" indent="0">
-              <a:buNone/>
-            </a:pPr>
-            <a:r>
-              <a:rPr lang="en-US" sz="1800" b="1" dirty="0">
-                <a:solidFill>
-                  <a:srgbClr val="FCA311"/>
-                </a:solidFill>
-                <a:latin typeface="Calibri" pitchFamily="34" charset="0"/>
-                <a:ea typeface="Calibri" pitchFamily="34" charset="-122"/>
-                <a:cs typeface="Calibri" pitchFamily="34" charset="-120"/>
-              </a:rPr>
-              <a:t>Gracias · ¿Preguntas?</a:t>
-            </a:r>
-            <a:endParaRPr lang="en-US" sz="1800" dirty="0"/>
           </a:p>
         </p:txBody>
       </p:sp>

</xml_diff>